<commit_message>
se actualiza diapositiva 2
</commit_message>
<xml_diff>
--- a/docs/Complejidad_Migracion_NET_a_Java_Hexagonal.pptx
+++ b/docs/Complejidad_Migracion_NET_a_Java_Hexagonal.pptx
@@ -7048,13 +7048,391 @@
               </a:lnSpc>
             </a:pPr>
             <a:r>
-              <a:rPr sz="1130" b="0" i="0">
+              <a:rPr sz="1130" b="0" i="0" dirty="0">
                 <a:solidFill>
                   <a:srgbClr val="667085"/>
                 </a:solidFill>
                 <a:latin typeface="Calibri"/>
               </a:rPr>
-              <a:t>lower(bytea) es un bug propio de Postgres. SQL Server, en muchas de sus configuraciones de texto (collations), no distingue mayúsculas de minúsculas por defecto — ahí el riesgo habría sido el opuesto: búsquedas que traen resultados de más (falsos positivos).</a:t>
+              <a:t>lower(</a:t>
+            </a:r>
+            <a:r>
+              <a:rPr sz="1130" b="0" i="0" dirty="0" err="1">
+                <a:solidFill>
+                  <a:srgbClr val="667085"/>
+                </a:solidFill>
+                <a:latin typeface="Calibri"/>
+              </a:rPr>
+              <a:t>bytea</a:t>
+            </a:r>
+            <a:r>
+              <a:rPr sz="1130" b="0" i="0" dirty="0">
+                <a:solidFill>
+                  <a:srgbClr val="667085"/>
+                </a:solidFill>
+                <a:latin typeface="Calibri"/>
+              </a:rPr>
+              <a:t>) es un bug </a:t>
+            </a:r>
+            <a:r>
+              <a:rPr sz="1130" b="0" i="0" dirty="0" err="1">
+                <a:solidFill>
+                  <a:srgbClr val="667085"/>
+                </a:solidFill>
+                <a:latin typeface="Calibri"/>
+              </a:rPr>
+              <a:t>propio</a:t>
+            </a:r>
+            <a:r>
+              <a:rPr sz="1130" b="0" i="0" dirty="0">
+                <a:solidFill>
+                  <a:srgbClr val="667085"/>
+                </a:solidFill>
+                <a:latin typeface="Calibri"/>
+              </a:rPr>
+              <a:t> de Postgres. SQL Server, </a:t>
+            </a:r>
+            <a:r>
+              <a:rPr sz="1130" b="0" i="0" dirty="0" err="1">
+                <a:solidFill>
+                  <a:srgbClr val="667085"/>
+                </a:solidFill>
+                <a:latin typeface="Calibri"/>
+              </a:rPr>
+              <a:t>en</a:t>
+            </a:r>
+            <a:r>
+              <a:rPr sz="1130" b="0" i="0" dirty="0">
+                <a:solidFill>
+                  <a:srgbClr val="667085"/>
+                </a:solidFill>
+                <a:latin typeface="Calibri"/>
+              </a:rPr>
+              <a:t> </a:t>
+            </a:r>
+            <a:r>
+              <a:rPr sz="1130" b="0" i="0" dirty="0" err="1">
+                <a:solidFill>
+                  <a:srgbClr val="667085"/>
+                </a:solidFill>
+                <a:latin typeface="Calibri"/>
+              </a:rPr>
+              <a:t>muchas</a:t>
+            </a:r>
+            <a:r>
+              <a:rPr sz="1130" b="0" i="0" dirty="0">
+                <a:solidFill>
+                  <a:srgbClr val="667085"/>
+                </a:solidFill>
+                <a:latin typeface="Calibri"/>
+              </a:rPr>
+              <a:t> de sus </a:t>
+            </a:r>
+            <a:r>
+              <a:rPr sz="1130" b="0" i="0" dirty="0" err="1">
+                <a:solidFill>
+                  <a:srgbClr val="667085"/>
+                </a:solidFill>
+                <a:latin typeface="Calibri"/>
+              </a:rPr>
+              <a:t>configuraciones</a:t>
+            </a:r>
+            <a:r>
+              <a:rPr sz="1130" b="0" i="0" dirty="0">
+                <a:solidFill>
+                  <a:srgbClr val="667085"/>
+                </a:solidFill>
+                <a:latin typeface="Calibri"/>
+              </a:rPr>
+              <a:t> de </a:t>
+            </a:r>
+            <a:r>
+              <a:rPr sz="1130" b="0" i="0" dirty="0" err="1">
+                <a:solidFill>
+                  <a:srgbClr val="667085"/>
+                </a:solidFill>
+                <a:latin typeface="Calibri"/>
+              </a:rPr>
+              <a:t>texto</a:t>
+            </a:r>
+            <a:r>
+              <a:rPr sz="1130" b="0" i="0" dirty="0">
+                <a:solidFill>
+                  <a:srgbClr val="667085"/>
+                </a:solidFill>
+                <a:latin typeface="Calibri"/>
+              </a:rPr>
+              <a:t> (collations), no distingue </a:t>
+            </a:r>
+            <a:r>
+              <a:rPr sz="1130" b="0" i="0" dirty="0" err="1">
+                <a:solidFill>
+                  <a:srgbClr val="667085"/>
+                </a:solidFill>
+                <a:latin typeface="Calibri"/>
+              </a:rPr>
+              <a:t>mayúsculas</a:t>
+            </a:r>
+            <a:r>
+              <a:rPr sz="1130" b="0" i="0" dirty="0">
+                <a:solidFill>
+                  <a:srgbClr val="667085"/>
+                </a:solidFill>
+                <a:latin typeface="Calibri"/>
+              </a:rPr>
+              <a:t> de </a:t>
+            </a:r>
+            <a:r>
+              <a:rPr sz="1130" b="0" i="0" dirty="0" err="1">
+                <a:solidFill>
+                  <a:srgbClr val="667085"/>
+                </a:solidFill>
+                <a:latin typeface="Calibri"/>
+              </a:rPr>
+              <a:t>minúsculas</a:t>
+            </a:r>
+            <a:r>
+              <a:rPr sz="1130" b="0" i="0" dirty="0">
+                <a:solidFill>
+                  <a:srgbClr val="667085"/>
+                </a:solidFill>
+                <a:latin typeface="Calibri"/>
+              </a:rPr>
+              <a:t> </a:t>
+            </a:r>
+            <a:r>
+              <a:rPr sz="1130" b="0" i="0" dirty="0" err="1">
+                <a:solidFill>
+                  <a:srgbClr val="667085"/>
+                </a:solidFill>
+                <a:latin typeface="Calibri"/>
+              </a:rPr>
+              <a:t>por</a:t>
+            </a:r>
+            <a:r>
+              <a:rPr sz="1130" b="0" i="0" dirty="0">
+                <a:solidFill>
+                  <a:srgbClr val="667085"/>
+                </a:solidFill>
+                <a:latin typeface="Calibri"/>
+              </a:rPr>
+              <a:t> </a:t>
+            </a:r>
+            <a:r>
+              <a:rPr sz="1130" b="0" i="0" dirty="0" err="1">
+                <a:solidFill>
+                  <a:srgbClr val="667085"/>
+                </a:solidFill>
+                <a:latin typeface="Calibri"/>
+              </a:rPr>
+              <a:t>defecto</a:t>
+            </a:r>
+            <a:r>
+              <a:rPr sz="1130" b="0" i="0" dirty="0">
+                <a:solidFill>
+                  <a:srgbClr val="667085"/>
+                </a:solidFill>
+                <a:latin typeface="Calibri"/>
+              </a:rPr>
+              <a:t> — ahí el </a:t>
+            </a:r>
+            <a:r>
+              <a:rPr sz="1130" b="0" i="0" dirty="0" err="1">
+                <a:solidFill>
+                  <a:srgbClr val="667085"/>
+                </a:solidFill>
+                <a:latin typeface="Calibri"/>
+              </a:rPr>
+              <a:t>riesgo</a:t>
+            </a:r>
+            <a:r>
+              <a:rPr sz="1130" b="0" i="0" dirty="0">
+                <a:solidFill>
+                  <a:srgbClr val="667085"/>
+                </a:solidFill>
+                <a:latin typeface="Calibri"/>
+              </a:rPr>
+              <a:t> </a:t>
+            </a:r>
+            <a:r>
+              <a:rPr sz="1130" b="0" i="0" dirty="0" err="1">
+                <a:solidFill>
+                  <a:srgbClr val="667085"/>
+                </a:solidFill>
+                <a:latin typeface="Calibri"/>
+              </a:rPr>
+              <a:t>habría</a:t>
+            </a:r>
+            <a:r>
+              <a:rPr sz="1130" b="0" i="0" dirty="0">
+                <a:solidFill>
+                  <a:srgbClr val="667085"/>
+                </a:solidFill>
+                <a:latin typeface="Calibri"/>
+              </a:rPr>
+              <a:t> </a:t>
+            </a:r>
+            <a:r>
+              <a:rPr sz="1130" b="0" i="0" dirty="0" err="1">
+                <a:solidFill>
+                  <a:srgbClr val="667085"/>
+                </a:solidFill>
+                <a:latin typeface="Calibri"/>
+              </a:rPr>
+              <a:t>sido</a:t>
+            </a:r>
+            <a:r>
+              <a:rPr sz="1130" b="0" i="0" dirty="0">
+                <a:solidFill>
+                  <a:srgbClr val="667085"/>
+                </a:solidFill>
+                <a:latin typeface="Calibri"/>
+              </a:rPr>
+              <a:t> el </a:t>
+            </a:r>
+            <a:r>
+              <a:rPr sz="1130" b="0" i="0" dirty="0" err="1">
+                <a:solidFill>
+                  <a:srgbClr val="667085"/>
+                </a:solidFill>
+                <a:latin typeface="Calibri"/>
+              </a:rPr>
+              <a:t>opuesto</a:t>
+            </a:r>
+            <a:r>
+              <a:rPr sz="1130" b="0" i="0" dirty="0">
+                <a:solidFill>
+                  <a:srgbClr val="667085"/>
+                </a:solidFill>
+                <a:latin typeface="Calibri"/>
+              </a:rPr>
+              <a:t>: </a:t>
+            </a:r>
+            <a:r>
+              <a:rPr sz="1130" b="0" i="0" dirty="0" err="1">
+                <a:solidFill>
+                  <a:srgbClr val="667085"/>
+                </a:solidFill>
+                <a:latin typeface="Calibri"/>
+              </a:rPr>
+              <a:t>búsquedas</a:t>
+            </a:r>
+            <a:r>
+              <a:rPr sz="1130" b="0" i="0" dirty="0">
+                <a:solidFill>
+                  <a:srgbClr val="667085"/>
+                </a:solidFill>
+                <a:latin typeface="Calibri"/>
+              </a:rPr>
+              <a:t> </a:t>
+            </a:r>
+            <a:r>
+              <a:rPr sz="1130" b="0" i="0" dirty="0" err="1">
+                <a:solidFill>
+                  <a:srgbClr val="667085"/>
+                </a:solidFill>
+                <a:latin typeface="Calibri"/>
+              </a:rPr>
+              <a:t>que</a:t>
+            </a:r>
+            <a:r>
+              <a:rPr sz="1130" b="0" i="0" dirty="0">
+                <a:solidFill>
+                  <a:srgbClr val="667085"/>
+                </a:solidFill>
+                <a:latin typeface="Calibri"/>
+              </a:rPr>
+              <a:t> </a:t>
+            </a:r>
+            <a:r>
+              <a:rPr sz="1130" b="0" i="0" dirty="0" err="1">
+                <a:solidFill>
+                  <a:srgbClr val="667085"/>
+                </a:solidFill>
+                <a:latin typeface="Calibri"/>
+              </a:rPr>
+              <a:t>traen</a:t>
+            </a:r>
+            <a:r>
+              <a:rPr sz="1130" b="0" i="0" dirty="0">
+                <a:solidFill>
+                  <a:srgbClr val="667085"/>
+                </a:solidFill>
+                <a:latin typeface="Calibri"/>
+              </a:rPr>
+              <a:t> </a:t>
+            </a:r>
+            <a:r>
+              <a:rPr sz="1130" b="0" i="0" dirty="0" err="1">
+                <a:solidFill>
+                  <a:srgbClr val="667085"/>
+                </a:solidFill>
+                <a:latin typeface="Calibri"/>
+              </a:rPr>
+              <a:t>resultados</a:t>
+            </a:r>
+            <a:r>
+              <a:rPr sz="1130" b="0" i="0" dirty="0">
+                <a:solidFill>
+                  <a:srgbClr val="667085"/>
+                </a:solidFill>
+                <a:latin typeface="Calibri"/>
+              </a:rPr>
+              <a:t> de </a:t>
+            </a:r>
+            <a:r>
+              <a:rPr sz="1130" b="0" i="0" dirty="0" err="1">
+                <a:solidFill>
+                  <a:srgbClr val="667085"/>
+                </a:solidFill>
+                <a:latin typeface="Calibri"/>
+              </a:rPr>
+              <a:t>más</a:t>
+            </a:r>
+            <a:r>
+              <a:rPr sz="1130" b="0" i="0" dirty="0">
+                <a:solidFill>
+                  <a:srgbClr val="667085"/>
+                </a:solidFill>
+                <a:latin typeface="Calibri"/>
+              </a:rPr>
+              <a:t> (</a:t>
+            </a:r>
+            <a:r>
+              <a:rPr sz="1130" b="0" i="0" dirty="0" err="1">
+                <a:solidFill>
+                  <a:srgbClr val="667085"/>
+                </a:solidFill>
+                <a:latin typeface="Calibri"/>
+              </a:rPr>
+              <a:t>falsos</a:t>
+            </a:r>
+            <a:r>
+              <a:rPr sz="1130" b="0" i="0" dirty="0">
+                <a:solidFill>
+                  <a:srgbClr val="667085"/>
+                </a:solidFill>
+                <a:latin typeface="Calibri"/>
+              </a:rPr>
+              <a:t> </a:t>
+            </a:r>
+            <a:r>
+              <a:rPr sz="1130" b="0" i="0" dirty="0" err="1">
+                <a:solidFill>
+                  <a:srgbClr val="667085"/>
+                </a:solidFill>
+                <a:latin typeface="Calibri"/>
+              </a:rPr>
+              <a:t>positivos</a:t>
+            </a:r>
+            <a:r>
+              <a:rPr sz="1130" b="0" i="0" dirty="0">
+                <a:solidFill>
+                  <a:srgbClr val="667085"/>
+                </a:solidFill>
+                <a:latin typeface="Calibri"/>
+              </a:rPr>
+              <a:t>).</a:t>
             </a:r>
           </a:p>
         </p:txBody>

</xml_diff>